<commit_message>
Remove 'illustrative concept' disclaimer line from Slide 5
</commit_message>
<xml_diff>
--- a/slides/mid_sem_presentation.pptx
+++ b/slides/mid_sem_presentation.pptx
@@ -6702,16 +6702,6 @@
           <a:lstStyle/>
           <a:p>
             <a:r>
-              <a:rPr sz="1500" i="1">
-                <a:solidFill>
-                  <a:srgbClr val="6B7280"/>
-                </a:solidFill>
-              </a:rPr>
-              <a:t>Illustrative concept, not this project's own results (those come in Phase 2) - a generic 4-category example of why a single marginal (pooled) coverage number can mislead.</a:t>
-            </a:r>
-          </a:p>
-          <a:p>
-            <a:r>
               <a:rPr sz="1500"/>
               <a:t>Marginal average across all 4 categories here = 90.5% - looks like the target is comfortably met.</a:t>
             </a:r>

</xml_diff>